<commit_message>
The original paper git repo was submoduled
</commit_message>
<xml_diff>
--- a/Paper presentation/StrDA_Canva_Style_Presentation.pptx
+++ b/Paper presentation/StrDA_Canva_Style_Presentation.pptx
@@ -5,21 +5,21 @@
     <p:sldMasterId id="2147483648" r:id="rId1"/>
   </p:sldMasterIdLst>
   <p:sldIdLst>
-    <p:sldId id="256" r:id="rId7"/>
-    <p:sldId id="257" r:id="rId8"/>
-    <p:sldId id="258" r:id="rId9"/>
-    <p:sldId id="259" r:id="rId10"/>
-    <p:sldId id="260" r:id="rId11"/>
-    <p:sldId id="261" r:id="rId12"/>
-    <p:sldId id="262" r:id="rId13"/>
-    <p:sldId id="263" r:id="rId14"/>
-    <p:sldId id="264" r:id="rId15"/>
-    <p:sldId id="265" r:id="rId16"/>
-    <p:sldId id="266" r:id="rId17"/>
-    <p:sldId id="267" r:id="rId18"/>
-    <p:sldId id="268" r:id="rId19"/>
+    <p:sldId id="256" r:id="rId2"/>
+    <p:sldId id="257" r:id="rId3"/>
+    <p:sldId id="258" r:id="rId4"/>
+    <p:sldId id="259" r:id="rId5"/>
+    <p:sldId id="260" r:id="rId6"/>
+    <p:sldId id="261" r:id="rId7"/>
+    <p:sldId id="262" r:id="rId8"/>
+    <p:sldId id="263" r:id="rId9"/>
+    <p:sldId id="264" r:id="rId10"/>
+    <p:sldId id="265" r:id="rId11"/>
+    <p:sldId id="266" r:id="rId12"/>
+    <p:sldId id="267" r:id="rId13"/>
+    <p:sldId id="268" r:id="rId14"/>
   </p:sldIdLst>
-  <p:sldSz cx="12191695" cy="6858000" type="screen4x3"/>
+  <p:sldSz cx="12192000" cy="6858000"/>
   <p:notesSz cx="6858000" cy="9144000"/>
   <p:defaultTextStyle>
     <a:defPPr>
@@ -116,6 +116,22 @@
       </a:defRPr>
     </a:lvl9pPr>
   </p:defaultTextStyle>
+  <p:extLst>
+    <p:ext uri="{EFAFB233-063F-42B5-8137-9DF3F51BA10A}">
+      <p15:sldGuideLst xmlns:p15="http://schemas.microsoft.com/office/powerpoint/2012/main">
+        <p15:guide id="1" orient="horz" pos="2160">
+          <p15:clr>
+            <a:srgbClr val="A4A3A4"/>
+          </p15:clr>
+        </p15:guide>
+        <p15:guide id="2" pos="2880">
+          <p15:clr>
+            <a:srgbClr val="A4A3A4"/>
+          </p15:clr>
+        </p15:guide>
+      </p15:sldGuideLst>
+    </p:ext>
+  </p:extLst>
 </p:presentation>
 </file>
 
@@ -157,10 +173,9 @@
           <a:lstStyle/>
           <a:p>
             <a:r>
-              <a:rPr lang="en-US" smtClean="0"/>
+              <a:rPr lang="en-US"/>
               <a:t>Click to edit Master title style</a:t>
             </a:r>
-            <a:endParaRPr lang="en-US"/>
           </a:p>
         </p:txBody>
       </p:sp>
@@ -276,10 +291,9 @@
           </a:lstStyle>
           <a:p>
             <a:r>
-              <a:rPr lang="en-US" smtClean="0"/>
+              <a:rPr lang="en-US"/>
               <a:t>Click to edit Master subtitle style</a:t>
             </a:r>
-            <a:endParaRPr lang="en-US"/>
           </a:p>
         </p:txBody>
       </p:sp>
@@ -300,7 +314,7 @@
           <a:p>
             <a:fld id="{5BCAD085-E8A6-8845-BD4E-CB4CCA059FC4}" type="datetimeFigureOut">
               <a:rPr lang="en-US" smtClean="0"/>
-              <a:t>1/27/13</a:t>
+              <a:t>9/8/2026</a:t>
             </a:fld>
             <a:endParaRPr lang="en-US"/>
           </a:p>
@@ -394,10 +408,9 @@
           <a:lstStyle/>
           <a:p>
             <a:r>
-              <a:rPr lang="en-US" smtClean="0"/>
+              <a:rPr lang="en-US"/>
               <a:t>Click to edit Master title style</a:t>
             </a:r>
-            <a:endParaRPr lang="en-US"/>
           </a:p>
         </p:txBody>
       </p:sp>
@@ -418,38 +431,37 @@
           <a:p>
             <a:pPr lvl="0"/>
             <a:r>
-              <a:rPr lang="en-US" smtClean="0"/>
+              <a:rPr lang="en-US"/>
               <a:t>Click to edit Master text styles</a:t>
             </a:r>
           </a:p>
           <a:p>
             <a:pPr lvl="1"/>
             <a:r>
-              <a:rPr lang="en-US" smtClean="0"/>
+              <a:rPr lang="en-US"/>
               <a:t>Second level</a:t>
             </a:r>
           </a:p>
           <a:p>
             <a:pPr lvl="2"/>
             <a:r>
-              <a:rPr lang="en-US" smtClean="0"/>
+              <a:rPr lang="en-US"/>
               <a:t>Third level</a:t>
             </a:r>
           </a:p>
           <a:p>
             <a:pPr lvl="3"/>
             <a:r>
-              <a:rPr lang="en-US" smtClean="0"/>
+              <a:rPr lang="en-US"/>
               <a:t>Fourth level</a:t>
             </a:r>
           </a:p>
           <a:p>
             <a:pPr lvl="4"/>
             <a:r>
-              <a:rPr lang="en-US" smtClean="0"/>
+              <a:rPr lang="en-US"/>
               <a:t>Fifth level</a:t>
             </a:r>
-            <a:endParaRPr lang="en-US"/>
           </a:p>
         </p:txBody>
       </p:sp>
@@ -470,7 +482,7 @@
           <a:p>
             <a:fld id="{5BCAD085-E8A6-8845-BD4E-CB4CCA059FC4}" type="datetimeFigureOut">
               <a:rPr lang="en-US" smtClean="0"/>
-              <a:t>1/27/13</a:t>
+              <a:t>9/8/2026</a:t>
             </a:fld>
             <a:endParaRPr lang="en-US"/>
           </a:p>
@@ -569,10 +581,9 @@
           <a:lstStyle/>
           <a:p>
             <a:r>
-              <a:rPr lang="en-US" smtClean="0"/>
+              <a:rPr lang="en-US"/>
               <a:t>Click to edit Master title style</a:t>
             </a:r>
-            <a:endParaRPr lang="en-US"/>
           </a:p>
         </p:txBody>
       </p:sp>
@@ -598,38 +609,37 @@
           <a:p>
             <a:pPr lvl="0"/>
             <a:r>
-              <a:rPr lang="en-US" smtClean="0"/>
+              <a:rPr lang="en-US"/>
               <a:t>Click to edit Master text styles</a:t>
             </a:r>
           </a:p>
           <a:p>
             <a:pPr lvl="1"/>
             <a:r>
-              <a:rPr lang="en-US" smtClean="0"/>
+              <a:rPr lang="en-US"/>
               <a:t>Second level</a:t>
             </a:r>
           </a:p>
           <a:p>
             <a:pPr lvl="2"/>
             <a:r>
-              <a:rPr lang="en-US" smtClean="0"/>
+              <a:rPr lang="en-US"/>
               <a:t>Third level</a:t>
             </a:r>
           </a:p>
           <a:p>
             <a:pPr lvl="3"/>
             <a:r>
-              <a:rPr lang="en-US" smtClean="0"/>
+              <a:rPr lang="en-US"/>
               <a:t>Fourth level</a:t>
             </a:r>
           </a:p>
           <a:p>
             <a:pPr lvl="4"/>
             <a:r>
-              <a:rPr lang="en-US" smtClean="0"/>
+              <a:rPr lang="en-US"/>
               <a:t>Fifth level</a:t>
             </a:r>
-            <a:endParaRPr lang="en-US"/>
           </a:p>
         </p:txBody>
       </p:sp>
@@ -650,7 +660,7 @@
           <a:p>
             <a:fld id="{5BCAD085-E8A6-8845-BD4E-CB4CCA059FC4}" type="datetimeFigureOut">
               <a:rPr lang="en-US" smtClean="0"/>
-              <a:t>1/27/13</a:t>
+              <a:t>9/8/2026</a:t>
             </a:fld>
             <a:endParaRPr lang="en-US"/>
           </a:p>
@@ -744,10 +754,9 @@
           <a:lstStyle/>
           <a:p>
             <a:r>
-              <a:rPr lang="en-US" smtClean="0"/>
+              <a:rPr lang="en-US"/>
               <a:t>Click to edit Master title style</a:t>
             </a:r>
-            <a:endParaRPr lang="en-US"/>
           </a:p>
         </p:txBody>
       </p:sp>
@@ -768,38 +777,37 @@
           <a:p>
             <a:pPr lvl="0"/>
             <a:r>
-              <a:rPr lang="en-US" smtClean="0"/>
+              <a:rPr lang="en-US"/>
               <a:t>Click to edit Master text styles</a:t>
             </a:r>
           </a:p>
           <a:p>
             <a:pPr lvl="1"/>
             <a:r>
-              <a:rPr lang="en-US" smtClean="0"/>
+              <a:rPr lang="en-US"/>
               <a:t>Second level</a:t>
             </a:r>
           </a:p>
           <a:p>
             <a:pPr lvl="2"/>
             <a:r>
-              <a:rPr lang="en-US" smtClean="0"/>
+              <a:rPr lang="en-US"/>
               <a:t>Third level</a:t>
             </a:r>
           </a:p>
           <a:p>
             <a:pPr lvl="3"/>
             <a:r>
-              <a:rPr lang="en-US" smtClean="0"/>
+              <a:rPr lang="en-US"/>
               <a:t>Fourth level</a:t>
             </a:r>
           </a:p>
           <a:p>
             <a:pPr lvl="4"/>
             <a:r>
-              <a:rPr lang="en-US" smtClean="0"/>
+              <a:rPr lang="en-US"/>
               <a:t>Fifth level</a:t>
             </a:r>
-            <a:endParaRPr lang="en-US"/>
           </a:p>
         </p:txBody>
       </p:sp>
@@ -820,7 +828,7 @@
           <a:p>
             <a:fld id="{5BCAD085-E8A6-8845-BD4E-CB4CCA059FC4}" type="datetimeFigureOut">
               <a:rPr lang="en-US" smtClean="0"/>
-              <a:t>1/27/13</a:t>
+              <a:t>9/8/2026</a:t>
             </a:fld>
             <a:endParaRPr lang="en-US"/>
           </a:p>
@@ -923,10 +931,9 @@
           </a:lstStyle>
           <a:p>
             <a:r>
-              <a:rPr lang="en-US" smtClean="0"/>
+              <a:rPr lang="en-US"/>
               <a:t>Click to edit Master title style</a:t>
             </a:r>
-            <a:endParaRPr lang="en-US"/>
           </a:p>
         </p:txBody>
       </p:sp>
@@ -1043,7 +1050,7 @@
           <a:p>
             <a:pPr lvl="0"/>
             <a:r>
-              <a:rPr lang="en-US" smtClean="0"/>
+              <a:rPr lang="en-US"/>
               <a:t>Click to edit Master text styles</a:t>
             </a:r>
           </a:p>
@@ -1066,7 +1073,7 @@
           <a:p>
             <a:fld id="{5BCAD085-E8A6-8845-BD4E-CB4CCA059FC4}" type="datetimeFigureOut">
               <a:rPr lang="en-US" smtClean="0"/>
-              <a:t>1/27/13</a:t>
+              <a:t>9/8/2026</a:t>
             </a:fld>
             <a:endParaRPr lang="en-US"/>
           </a:p>
@@ -1160,10 +1167,9 @@
           <a:lstStyle/>
           <a:p>
             <a:r>
-              <a:rPr lang="en-US" smtClean="0"/>
+              <a:rPr lang="en-US"/>
               <a:t>Click to edit Master title style</a:t>
             </a:r>
-            <a:endParaRPr lang="en-US"/>
           </a:p>
         </p:txBody>
       </p:sp>
@@ -1217,38 +1223,37 @@
           <a:p>
             <a:pPr lvl="0"/>
             <a:r>
-              <a:rPr lang="en-US" smtClean="0"/>
+              <a:rPr lang="en-US"/>
               <a:t>Click to edit Master text styles</a:t>
             </a:r>
           </a:p>
           <a:p>
             <a:pPr lvl="1"/>
             <a:r>
-              <a:rPr lang="en-US" smtClean="0"/>
+              <a:rPr lang="en-US"/>
               <a:t>Second level</a:t>
             </a:r>
           </a:p>
           <a:p>
             <a:pPr lvl="2"/>
             <a:r>
-              <a:rPr lang="en-US" smtClean="0"/>
+              <a:rPr lang="en-US"/>
               <a:t>Third level</a:t>
             </a:r>
           </a:p>
           <a:p>
             <a:pPr lvl="3"/>
             <a:r>
-              <a:rPr lang="en-US" smtClean="0"/>
+              <a:rPr lang="en-US"/>
               <a:t>Fourth level</a:t>
             </a:r>
           </a:p>
           <a:p>
             <a:pPr lvl="4"/>
             <a:r>
-              <a:rPr lang="en-US" smtClean="0"/>
+              <a:rPr lang="en-US"/>
               <a:t>Fifth level</a:t>
             </a:r>
-            <a:endParaRPr lang="en-US"/>
           </a:p>
         </p:txBody>
       </p:sp>
@@ -1302,38 +1307,37 @@
           <a:p>
             <a:pPr lvl="0"/>
             <a:r>
-              <a:rPr lang="en-US" smtClean="0"/>
+              <a:rPr lang="en-US"/>
               <a:t>Click to edit Master text styles</a:t>
             </a:r>
           </a:p>
           <a:p>
             <a:pPr lvl="1"/>
             <a:r>
-              <a:rPr lang="en-US" smtClean="0"/>
+              <a:rPr lang="en-US"/>
               <a:t>Second level</a:t>
             </a:r>
           </a:p>
           <a:p>
             <a:pPr lvl="2"/>
             <a:r>
-              <a:rPr lang="en-US" smtClean="0"/>
+              <a:rPr lang="en-US"/>
               <a:t>Third level</a:t>
             </a:r>
           </a:p>
           <a:p>
             <a:pPr lvl="3"/>
             <a:r>
-              <a:rPr lang="en-US" smtClean="0"/>
+              <a:rPr lang="en-US"/>
               <a:t>Fourth level</a:t>
             </a:r>
           </a:p>
           <a:p>
             <a:pPr lvl="4"/>
             <a:r>
-              <a:rPr lang="en-US" smtClean="0"/>
+              <a:rPr lang="en-US"/>
               <a:t>Fifth level</a:t>
             </a:r>
-            <a:endParaRPr lang="en-US"/>
           </a:p>
         </p:txBody>
       </p:sp>
@@ -1354,7 +1358,7 @@
           <a:p>
             <a:fld id="{5BCAD085-E8A6-8845-BD4E-CB4CCA059FC4}" type="datetimeFigureOut">
               <a:rPr lang="en-US" smtClean="0"/>
-              <a:t>1/27/13</a:t>
+              <a:t>9/8/2026</a:t>
             </a:fld>
             <a:endParaRPr lang="en-US"/>
           </a:p>
@@ -1452,10 +1456,9 @@
           </a:lstStyle>
           <a:p>
             <a:r>
-              <a:rPr lang="en-US" smtClean="0"/>
+              <a:rPr lang="en-US"/>
               <a:t>Click to edit Master title style</a:t>
             </a:r>
-            <a:endParaRPr lang="en-US"/>
           </a:p>
         </p:txBody>
       </p:sp>
@@ -1518,7 +1521,7 @@
           <a:p>
             <a:pPr lvl="0"/>
             <a:r>
-              <a:rPr lang="en-US" smtClean="0"/>
+              <a:rPr lang="en-US"/>
               <a:t>Click to edit Master text styles</a:t>
             </a:r>
           </a:p>
@@ -1574,38 +1577,37 @@
           <a:p>
             <a:pPr lvl="0"/>
             <a:r>
-              <a:rPr lang="en-US" smtClean="0"/>
+              <a:rPr lang="en-US"/>
               <a:t>Click to edit Master text styles</a:t>
             </a:r>
           </a:p>
           <a:p>
             <a:pPr lvl="1"/>
             <a:r>
-              <a:rPr lang="en-US" smtClean="0"/>
+              <a:rPr lang="en-US"/>
               <a:t>Second level</a:t>
             </a:r>
           </a:p>
           <a:p>
             <a:pPr lvl="2"/>
             <a:r>
-              <a:rPr lang="en-US" smtClean="0"/>
+              <a:rPr lang="en-US"/>
               <a:t>Third level</a:t>
             </a:r>
           </a:p>
           <a:p>
             <a:pPr lvl="3"/>
             <a:r>
-              <a:rPr lang="en-US" smtClean="0"/>
+              <a:rPr lang="en-US"/>
               <a:t>Fourth level</a:t>
             </a:r>
           </a:p>
           <a:p>
             <a:pPr lvl="4"/>
             <a:r>
-              <a:rPr lang="en-US" smtClean="0"/>
+              <a:rPr lang="en-US"/>
               <a:t>Fifth level</a:t>
             </a:r>
-            <a:endParaRPr lang="en-US"/>
           </a:p>
         </p:txBody>
       </p:sp>
@@ -1668,7 +1670,7 @@
           <a:p>
             <a:pPr lvl="0"/>
             <a:r>
-              <a:rPr lang="en-US" smtClean="0"/>
+              <a:rPr lang="en-US"/>
               <a:t>Click to edit Master text styles</a:t>
             </a:r>
           </a:p>
@@ -1724,38 +1726,37 @@
           <a:p>
             <a:pPr lvl="0"/>
             <a:r>
-              <a:rPr lang="en-US" smtClean="0"/>
+              <a:rPr lang="en-US"/>
               <a:t>Click to edit Master text styles</a:t>
             </a:r>
           </a:p>
           <a:p>
             <a:pPr lvl="1"/>
             <a:r>
-              <a:rPr lang="en-US" smtClean="0"/>
+              <a:rPr lang="en-US"/>
               <a:t>Second level</a:t>
             </a:r>
           </a:p>
           <a:p>
             <a:pPr lvl="2"/>
             <a:r>
-              <a:rPr lang="en-US" smtClean="0"/>
+              <a:rPr lang="en-US"/>
               <a:t>Third level</a:t>
             </a:r>
           </a:p>
           <a:p>
             <a:pPr lvl="3"/>
             <a:r>
-              <a:rPr lang="en-US" smtClean="0"/>
+              <a:rPr lang="en-US"/>
               <a:t>Fourth level</a:t>
             </a:r>
           </a:p>
           <a:p>
             <a:pPr lvl="4"/>
             <a:r>
-              <a:rPr lang="en-US" smtClean="0"/>
+              <a:rPr lang="en-US"/>
               <a:t>Fifth level</a:t>
             </a:r>
-            <a:endParaRPr lang="en-US"/>
           </a:p>
         </p:txBody>
       </p:sp>
@@ -1776,7 +1777,7 @@
           <a:p>
             <a:fld id="{5BCAD085-E8A6-8845-BD4E-CB4CCA059FC4}" type="datetimeFigureOut">
               <a:rPr lang="en-US" smtClean="0"/>
-              <a:t>1/27/13</a:t>
+              <a:t>9/8/2026</a:t>
             </a:fld>
             <a:endParaRPr lang="en-US"/>
           </a:p>
@@ -1870,10 +1871,9 @@
           <a:lstStyle/>
           <a:p>
             <a:r>
-              <a:rPr lang="en-US" smtClean="0"/>
+              <a:rPr lang="en-US"/>
               <a:t>Click to edit Master title style</a:t>
             </a:r>
-            <a:endParaRPr lang="en-US"/>
           </a:p>
         </p:txBody>
       </p:sp>
@@ -1894,7 +1894,7 @@
           <a:p>
             <a:fld id="{5BCAD085-E8A6-8845-BD4E-CB4CCA059FC4}" type="datetimeFigureOut">
               <a:rPr lang="en-US" smtClean="0"/>
-              <a:t>1/27/13</a:t>
+              <a:t>9/8/2026</a:t>
             </a:fld>
             <a:endParaRPr lang="en-US"/>
           </a:p>
@@ -1989,7 +1989,7 @@
           <a:p>
             <a:fld id="{5BCAD085-E8A6-8845-BD4E-CB4CCA059FC4}" type="datetimeFigureOut">
               <a:rPr lang="en-US" smtClean="0"/>
-              <a:t>1/27/13</a:t>
+              <a:t>9/8/2026</a:t>
             </a:fld>
             <a:endParaRPr lang="en-US"/>
           </a:p>
@@ -2092,10 +2092,9 @@
           </a:lstStyle>
           <a:p>
             <a:r>
-              <a:rPr lang="en-US" smtClean="0"/>
+              <a:rPr lang="en-US"/>
               <a:t>Click to edit Master title style</a:t>
             </a:r>
-            <a:endParaRPr lang="en-US"/>
           </a:p>
         </p:txBody>
       </p:sp>
@@ -2149,38 +2148,37 @@
           <a:p>
             <a:pPr lvl="0"/>
             <a:r>
-              <a:rPr lang="en-US" smtClean="0"/>
+              <a:rPr lang="en-US"/>
               <a:t>Click to edit Master text styles</a:t>
             </a:r>
           </a:p>
           <a:p>
             <a:pPr lvl="1"/>
             <a:r>
-              <a:rPr lang="en-US" smtClean="0"/>
+              <a:rPr lang="en-US"/>
               <a:t>Second level</a:t>
             </a:r>
           </a:p>
           <a:p>
             <a:pPr lvl="2"/>
             <a:r>
-              <a:rPr lang="en-US" smtClean="0"/>
+              <a:rPr lang="en-US"/>
               <a:t>Third level</a:t>
             </a:r>
           </a:p>
           <a:p>
             <a:pPr lvl="3"/>
             <a:r>
-              <a:rPr lang="en-US" smtClean="0"/>
+              <a:rPr lang="en-US"/>
               <a:t>Fourth level</a:t>
             </a:r>
           </a:p>
           <a:p>
             <a:pPr lvl="4"/>
             <a:r>
-              <a:rPr lang="en-US" smtClean="0"/>
+              <a:rPr lang="en-US"/>
               <a:t>Fifth level</a:t>
             </a:r>
-            <a:endParaRPr lang="en-US"/>
           </a:p>
         </p:txBody>
       </p:sp>
@@ -2243,7 +2241,7 @@
           <a:p>
             <a:pPr lvl="0"/>
             <a:r>
-              <a:rPr lang="en-US" smtClean="0"/>
+              <a:rPr lang="en-US"/>
               <a:t>Click to edit Master text styles</a:t>
             </a:r>
           </a:p>
@@ -2266,7 +2264,7 @@
           <a:p>
             <a:fld id="{5BCAD085-E8A6-8845-BD4E-CB4CCA059FC4}" type="datetimeFigureOut">
               <a:rPr lang="en-US" smtClean="0"/>
-              <a:t>1/27/13</a:t>
+              <a:t>9/8/2026</a:t>
             </a:fld>
             <a:endParaRPr lang="en-US"/>
           </a:p>
@@ -2369,10 +2367,9 @@
           </a:lstStyle>
           <a:p>
             <a:r>
-              <a:rPr lang="en-US" smtClean="0"/>
+              <a:rPr lang="en-US"/>
               <a:t>Click to edit Master title style</a:t>
             </a:r>
-            <a:endParaRPr lang="en-US"/>
           </a:p>
         </p:txBody>
       </p:sp>
@@ -2496,7 +2493,7 @@
           <a:p>
             <a:pPr lvl="0"/>
             <a:r>
-              <a:rPr lang="en-US" smtClean="0"/>
+              <a:rPr lang="en-US"/>
               <a:t>Click to edit Master text styles</a:t>
             </a:r>
           </a:p>
@@ -2519,7 +2516,7 @@
           <a:p>
             <a:fld id="{5BCAD085-E8A6-8845-BD4E-CB4CCA059FC4}" type="datetimeFigureOut">
               <a:rPr lang="en-US" smtClean="0"/>
-              <a:t>1/27/13</a:t>
+              <a:t>9/8/2026</a:t>
             </a:fld>
             <a:endParaRPr lang="en-US"/>
           </a:p>
@@ -2628,10 +2625,9 @@
           <a:lstStyle/>
           <a:p>
             <a:r>
-              <a:rPr lang="en-US" smtClean="0"/>
+              <a:rPr lang="en-US"/>
               <a:t>Click to edit Master title style</a:t>
             </a:r>
-            <a:endParaRPr lang="en-US"/>
           </a:p>
         </p:txBody>
       </p:sp>
@@ -2662,38 +2658,37 @@
           <a:p>
             <a:pPr lvl="0"/>
             <a:r>
-              <a:rPr lang="en-US" smtClean="0"/>
+              <a:rPr lang="en-US"/>
               <a:t>Click to edit Master text styles</a:t>
             </a:r>
           </a:p>
           <a:p>
             <a:pPr lvl="1"/>
             <a:r>
-              <a:rPr lang="en-US" smtClean="0"/>
+              <a:rPr lang="en-US"/>
               <a:t>Second level</a:t>
             </a:r>
           </a:p>
           <a:p>
             <a:pPr lvl="2"/>
             <a:r>
-              <a:rPr lang="en-US" smtClean="0"/>
+              <a:rPr lang="en-US"/>
               <a:t>Third level</a:t>
             </a:r>
           </a:p>
           <a:p>
             <a:pPr lvl="3"/>
             <a:r>
-              <a:rPr lang="en-US" smtClean="0"/>
+              <a:rPr lang="en-US"/>
               <a:t>Fourth level</a:t>
             </a:r>
           </a:p>
           <a:p>
             <a:pPr lvl="4"/>
             <a:r>
-              <a:rPr lang="en-US" smtClean="0"/>
+              <a:rPr lang="en-US"/>
               <a:t>Fifth level</a:t>
             </a:r>
-            <a:endParaRPr lang="en-US"/>
           </a:p>
         </p:txBody>
       </p:sp>
@@ -2732,7 +2727,7 @@
           <a:p>
             <a:fld id="{5BCAD085-E8A6-8845-BD4E-CB4CCA059FC4}" type="datetimeFigureOut">
               <a:rPr lang="en-US" smtClean="0"/>
-              <a:t>1/27/13</a:t>
+              <a:t>9/8/2026</a:t>
             </a:fld>
             <a:endParaRPr lang="en-US"/>
           </a:p>
@@ -3091,7 +3086,7 @@
 </file>
 
 <file path=ppt/slides/slide1.xml><?xml version="1.0" encoding="utf-8"?>
-<p:sld xmlns:a="http://schemas.openxmlformats.org/drawingml/2006/main" xmlns:p="http://schemas.openxmlformats.org/presentationml/2006/main" xmlns:r="http://schemas.openxmlformats.org/officeDocument/2006/relationships">
+<p:sld xmlns:a="http://schemas.openxmlformats.org/drawingml/2006/main" xmlns:r="http://schemas.openxmlformats.org/officeDocument/2006/relationships" xmlns:p="http://schemas.openxmlformats.org/presentationml/2006/main">
   <p:cSld>
     <p:bg>
       <p:bgPr>
@@ -3107,7 +3102,14 @@
         <p:cNvGrpSpPr/>
         <p:nvPr/>
       </p:nvGrpSpPr>
-      <p:grpSpPr/>
+      <p:grpSpPr>
+        <a:xfrm>
+          <a:off x="0" y="0"/>
+          <a:ext cx="0" cy="0"/>
+          <a:chOff x="0" y="0"/>
+          <a:chExt cx="0" cy="0"/>
+        </a:xfrm>
+      </p:grpSpPr>
       <p:sp>
         <p:nvSpPr>
           <p:cNvPr id="2" name="Oval 1"/>
@@ -3148,6 +3150,7 @@
           <a:lstStyle/>
           <a:p>
             <a:pPr algn="ctr"/>
+            <a:endParaRPr/>
           </a:p>
         </p:txBody>
       </p:sp>
@@ -3191,6 +3194,7 @@
           <a:lstStyle/>
           <a:p>
             <a:pPr algn="ctr"/>
+            <a:endParaRPr/>
           </a:p>
         </p:txBody>
       </p:sp>
@@ -3234,6 +3238,7 @@
           <a:lstStyle/>
           <a:p>
             <a:pPr algn="ctr"/>
+            <a:endParaRPr/>
           </a:p>
         </p:txBody>
       </p:sp>
@@ -3277,6 +3282,7 @@
           <a:lstStyle/>
           <a:p>
             <a:pPr algn="ctr"/>
+            <a:endParaRPr/>
           </a:p>
         </p:txBody>
       </p:sp>
@@ -3510,6 +3516,7 @@
           <a:lstStyle/>
           <a:p>
             <a:pPr algn="ctr"/>
+            <a:endParaRPr/>
           </a:p>
         </p:txBody>
       </p:sp>
@@ -3589,6 +3596,7 @@
           <a:lstStyle/>
           <a:p>
             <a:pPr algn="ctr"/>
+            <a:endParaRPr/>
           </a:p>
         </p:txBody>
       </p:sp>
@@ -3634,6 +3642,7 @@
           <a:lstStyle/>
           <a:p>
             <a:pPr algn="ctr"/>
+            <a:endParaRPr/>
           </a:p>
         </p:txBody>
       </p:sp>
@@ -3713,6 +3722,7 @@
           <a:lstStyle/>
           <a:p>
             <a:pPr algn="ctr"/>
+            <a:endParaRPr/>
           </a:p>
         </p:txBody>
       </p:sp>
@@ -3758,6 +3768,7 @@
           <a:lstStyle/>
           <a:p>
             <a:pPr algn="ctr"/>
+            <a:endParaRPr/>
           </a:p>
         </p:txBody>
       </p:sp>
@@ -3837,6 +3848,7 @@
           <a:lstStyle/>
           <a:p>
             <a:pPr algn="ctr"/>
+            <a:endParaRPr/>
           </a:p>
         </p:txBody>
       </p:sp>
@@ -3882,6 +3894,7 @@
           <a:lstStyle/>
           <a:p>
             <a:pPr algn="ctr"/>
+            <a:endParaRPr/>
           </a:p>
         </p:txBody>
       </p:sp>
@@ -3930,7 +3943,7 @@
         <p:spPr>
           <a:xfrm>
             <a:off x="8412480" y="5468112"/>
-            <a:ext cx="2834640" cy="640080"/>
+            <a:ext cx="2834640" cy="646331"/>
           </a:xfrm>
           <a:prstGeom prst="rect">
             <a:avLst/>
@@ -3952,12 +3965,28 @@
               </a:defRPr>
             </a:pPr>
             <a:r>
+              <a:rPr dirty="0"/>
               <a:t>Presented by</a:t>
             </a:r>
-            <a:br/>
-            <a:r>
-              <a:t>Samiru Nuwanaka</a:t>
-            </a:r>
+            <a:br>
+              <a:rPr dirty="0"/>
+            </a:br>
+            <a:r>
+              <a:rPr lang="en-US" dirty="0" err="1"/>
+              <a:t>VisionHeart</a:t>
+            </a:r>
+            <a:endParaRPr lang="en-US" dirty="0"/>
+          </a:p>
+          <a:p>
+            <a:pPr algn="r">
+              <a:defRPr sz="1200" b="1">
+                <a:solidFill>
+                  <a:srgbClr val="182230"/>
+                </a:solidFill>
+                <a:latin typeface="Aptos"/>
+              </a:defRPr>
+            </a:pPr>
+            <a:endParaRPr dirty="0"/>
           </a:p>
         </p:txBody>
       </p:sp>
@@ -4042,7 +4071,7 @@
 </file>
 
 <file path=ppt/slides/slide10.xml><?xml version="1.0" encoding="utf-8"?>
-<p:sld xmlns:a="http://schemas.openxmlformats.org/drawingml/2006/main" xmlns:p="http://schemas.openxmlformats.org/presentationml/2006/main" xmlns:r="http://schemas.openxmlformats.org/officeDocument/2006/relationships">
+<p:sld xmlns:a="http://schemas.openxmlformats.org/drawingml/2006/main" xmlns:r="http://schemas.openxmlformats.org/officeDocument/2006/relationships" xmlns:p="http://schemas.openxmlformats.org/presentationml/2006/main">
   <p:cSld>
     <p:bg>
       <p:bgPr>
@@ -4058,7 +4087,14 @@
         <p:cNvGrpSpPr/>
         <p:nvPr/>
       </p:nvGrpSpPr>
-      <p:grpSpPr/>
+      <p:grpSpPr>
+        <a:xfrm>
+          <a:off x="0" y="0"/>
+          <a:ext cx="0" cy="0"/>
+          <a:chOff x="0" y="0"/>
+          <a:chExt cx="0" cy="0"/>
+        </a:xfrm>
+      </p:grpSpPr>
       <p:sp>
         <p:nvSpPr>
           <p:cNvPr id="2" name="TextBox 1"/>
@@ -4209,6 +4245,7 @@
           <a:lstStyle/>
           <a:p>
             <a:pPr algn="ctr"/>
+            <a:endParaRPr/>
           </a:p>
         </p:txBody>
       </p:sp>
@@ -4252,6 +4289,7 @@
           <a:lstStyle/>
           <a:p>
             <a:pPr algn="ctr"/>
+            <a:endParaRPr/>
           </a:p>
         </p:txBody>
       </p:sp>
@@ -4403,6 +4441,7 @@
           <a:lstStyle/>
           <a:p>
             <a:pPr algn="ctr"/>
+            <a:endParaRPr/>
           </a:p>
         </p:txBody>
       </p:sp>
@@ -4446,6 +4485,7 @@
           <a:lstStyle/>
           <a:p>
             <a:pPr algn="ctr"/>
+            <a:endParaRPr/>
           </a:p>
         </p:txBody>
       </p:sp>
@@ -4489,6 +4529,7 @@
           <a:lstStyle/>
           <a:p>
             <a:pPr algn="ctr"/>
+            <a:endParaRPr/>
           </a:p>
         </p:txBody>
       </p:sp>
@@ -4532,6 +4573,7 @@
           <a:lstStyle/>
           <a:p>
             <a:pPr algn="ctr"/>
+            <a:endParaRPr/>
           </a:p>
         </p:txBody>
       </p:sp>
@@ -4575,6 +4617,7 @@
           <a:lstStyle/>
           <a:p>
             <a:pPr algn="ctr"/>
+            <a:endParaRPr/>
           </a:p>
         </p:txBody>
       </p:sp>
@@ -4618,6 +4661,7 @@
           <a:lstStyle/>
           <a:p>
             <a:pPr algn="ctr"/>
+            <a:endParaRPr/>
           </a:p>
         </p:txBody>
       </p:sp>
@@ -4661,6 +4705,7 @@
           <a:lstStyle/>
           <a:p>
             <a:pPr algn="ctr"/>
+            <a:endParaRPr/>
           </a:p>
         </p:txBody>
       </p:sp>
@@ -4704,6 +4749,7 @@
           <a:lstStyle/>
           <a:p>
             <a:pPr algn="ctr"/>
+            <a:endParaRPr/>
           </a:p>
         </p:txBody>
       </p:sp>
@@ -4747,6 +4793,7 @@
           <a:lstStyle/>
           <a:p>
             <a:pPr algn="ctr"/>
+            <a:endParaRPr/>
           </a:p>
         </p:txBody>
       </p:sp>
@@ -4790,6 +4837,7 @@
           <a:lstStyle/>
           <a:p>
             <a:pPr algn="ctr"/>
+            <a:endParaRPr/>
           </a:p>
         </p:txBody>
       </p:sp>
@@ -4833,6 +4881,7 @@
           <a:lstStyle/>
           <a:p>
             <a:pPr algn="ctr"/>
+            <a:endParaRPr/>
           </a:p>
         </p:txBody>
       </p:sp>
@@ -4876,6 +4925,7 @@
           <a:lstStyle/>
           <a:p>
             <a:pPr algn="ctr"/>
+            <a:endParaRPr/>
           </a:p>
         </p:txBody>
       </p:sp>
@@ -4919,6 +4969,7 @@
           <a:lstStyle/>
           <a:p>
             <a:pPr algn="ctr"/>
+            <a:endParaRPr/>
           </a:p>
         </p:txBody>
       </p:sp>
@@ -4962,6 +5013,7 @@
           <a:lstStyle/>
           <a:p>
             <a:pPr algn="ctr"/>
+            <a:endParaRPr/>
           </a:p>
         </p:txBody>
       </p:sp>
@@ -5005,6 +5057,7 @@
           <a:lstStyle/>
           <a:p>
             <a:pPr algn="ctr"/>
+            <a:endParaRPr/>
           </a:p>
         </p:txBody>
       </p:sp>
@@ -5048,6 +5101,7 @@
           <a:lstStyle/>
           <a:p>
             <a:pPr algn="ctr"/>
+            <a:endParaRPr/>
           </a:p>
         </p:txBody>
       </p:sp>
@@ -5091,6 +5145,7 @@
           <a:lstStyle/>
           <a:p>
             <a:pPr algn="ctr"/>
+            <a:endParaRPr/>
           </a:p>
         </p:txBody>
       </p:sp>
@@ -5134,6 +5189,7 @@
           <a:lstStyle/>
           <a:p>
             <a:pPr algn="ctr"/>
+            <a:endParaRPr/>
           </a:p>
         </p:txBody>
       </p:sp>
@@ -5251,6 +5307,7 @@
           <a:lstStyle/>
           <a:p>
             <a:pPr algn="ctr"/>
+            <a:endParaRPr/>
           </a:p>
         </p:txBody>
       </p:sp>
@@ -5294,6 +5351,7 @@
           <a:lstStyle/>
           <a:p>
             <a:pPr algn="ctr"/>
+            <a:endParaRPr/>
           </a:p>
         </p:txBody>
       </p:sp>
@@ -5447,6 +5505,7 @@
           <a:lstStyle/>
           <a:p>
             <a:pPr algn="ctr"/>
+            <a:endParaRPr/>
           </a:p>
         </p:txBody>
       </p:sp>
@@ -5564,6 +5623,7 @@
           <a:lstStyle/>
           <a:p>
             <a:pPr algn="ctr"/>
+            <a:endParaRPr/>
           </a:p>
         </p:txBody>
       </p:sp>
@@ -5756,7 +5816,7 @@
 </file>
 
 <file path=ppt/slides/slide11.xml><?xml version="1.0" encoding="utf-8"?>
-<p:sld xmlns:a="http://schemas.openxmlformats.org/drawingml/2006/main" xmlns:p="http://schemas.openxmlformats.org/presentationml/2006/main" xmlns:r="http://schemas.openxmlformats.org/officeDocument/2006/relationships">
+<p:sld xmlns:a="http://schemas.openxmlformats.org/drawingml/2006/main" xmlns:r="http://schemas.openxmlformats.org/officeDocument/2006/relationships" xmlns:p="http://schemas.openxmlformats.org/presentationml/2006/main">
   <p:cSld>
     <p:bg>
       <p:bgPr>
@@ -5772,7 +5832,14 @@
         <p:cNvGrpSpPr/>
         <p:nvPr/>
       </p:nvGrpSpPr>
-      <p:grpSpPr/>
+      <p:grpSpPr>
+        <a:xfrm>
+          <a:off x="0" y="0"/>
+          <a:ext cx="0" cy="0"/>
+          <a:chOff x="0" y="0"/>
+          <a:chExt cx="0" cy="0"/>
+        </a:xfrm>
+      </p:grpSpPr>
       <p:sp>
         <p:nvSpPr>
           <p:cNvPr id="2" name="TextBox 1"/>
@@ -5923,6 +5990,7 @@
           <a:lstStyle/>
           <a:p>
             <a:pPr algn="ctr"/>
+            <a:endParaRPr/>
           </a:p>
         </p:txBody>
       </p:sp>
@@ -5966,6 +6034,7 @@
           <a:lstStyle/>
           <a:p>
             <a:pPr algn="ctr"/>
+            <a:endParaRPr/>
           </a:p>
         </p:txBody>
       </p:sp>
@@ -6191,6 +6260,7 @@
           <a:lstStyle/>
           <a:p>
             <a:pPr algn="ctr"/>
+            <a:endParaRPr/>
           </a:p>
         </p:txBody>
       </p:sp>
@@ -6234,6 +6304,7 @@
           <a:lstStyle/>
           <a:p>
             <a:pPr algn="ctr"/>
+            <a:endParaRPr/>
           </a:p>
         </p:txBody>
       </p:sp>
@@ -6459,6 +6530,7 @@
           <a:lstStyle/>
           <a:p>
             <a:pPr algn="ctr"/>
+            <a:endParaRPr/>
           </a:p>
         </p:txBody>
       </p:sp>
@@ -6502,6 +6574,7 @@
           <a:lstStyle/>
           <a:p>
             <a:pPr algn="ctr"/>
+            <a:endParaRPr/>
           </a:p>
         </p:txBody>
       </p:sp>
@@ -6727,6 +6800,7 @@
           <a:lstStyle/>
           <a:p>
             <a:pPr algn="ctr"/>
+            <a:endParaRPr/>
           </a:p>
         </p:txBody>
       </p:sp>
@@ -6770,6 +6844,7 @@
           <a:lstStyle/>
           <a:p>
             <a:pPr algn="ctr"/>
+            <a:endParaRPr/>
           </a:p>
         </p:txBody>
       </p:sp>
@@ -7029,6 +7104,7 @@
           <a:lstStyle/>
           <a:p>
             <a:pPr algn="ctr"/>
+            <a:endParaRPr/>
           </a:p>
         </p:txBody>
       </p:sp>
@@ -7108,6 +7184,7 @@
           <a:lstStyle/>
           <a:p>
             <a:pPr algn="ctr"/>
+            <a:endParaRPr/>
           </a:p>
         </p:txBody>
       </p:sp>
@@ -7187,6 +7264,7 @@
           <a:lstStyle/>
           <a:p>
             <a:pPr algn="ctr"/>
+            <a:endParaRPr/>
           </a:p>
         </p:txBody>
       </p:sp>
@@ -7307,7 +7385,7 @@
 </file>
 
 <file path=ppt/slides/slide12.xml><?xml version="1.0" encoding="utf-8"?>
-<p:sld xmlns:a="http://schemas.openxmlformats.org/drawingml/2006/main" xmlns:p="http://schemas.openxmlformats.org/presentationml/2006/main" xmlns:r="http://schemas.openxmlformats.org/officeDocument/2006/relationships">
+<p:sld xmlns:a="http://schemas.openxmlformats.org/drawingml/2006/main" xmlns:r="http://schemas.openxmlformats.org/officeDocument/2006/relationships" xmlns:p="http://schemas.openxmlformats.org/presentationml/2006/main">
   <p:cSld>
     <p:bg>
       <p:bgPr>
@@ -7323,7 +7401,14 @@
         <p:cNvGrpSpPr/>
         <p:nvPr/>
       </p:nvGrpSpPr>
-      <p:grpSpPr/>
+      <p:grpSpPr>
+        <a:xfrm>
+          <a:off x="0" y="0"/>
+          <a:ext cx="0" cy="0"/>
+          <a:chOff x="0" y="0"/>
+          <a:chExt cx="0" cy="0"/>
+        </a:xfrm>
+      </p:grpSpPr>
       <p:sp>
         <p:nvSpPr>
           <p:cNvPr id="2" name="TextBox 1"/>
@@ -7474,6 +7559,7 @@
           <a:lstStyle/>
           <a:p>
             <a:pPr algn="ctr"/>
+            <a:endParaRPr/>
           </a:p>
         </p:txBody>
       </p:sp>
@@ -7627,6 +7713,7 @@
           <a:lstStyle/>
           <a:p>
             <a:pPr algn="ctr"/>
+            <a:endParaRPr/>
           </a:p>
         </p:txBody>
       </p:sp>
@@ -7780,6 +7867,7 @@
           <a:lstStyle/>
           <a:p>
             <a:pPr algn="ctr"/>
+            <a:endParaRPr/>
           </a:p>
         </p:txBody>
       </p:sp>
@@ -7933,6 +8021,7 @@
           <a:lstStyle/>
           <a:p>
             <a:pPr algn="ctr"/>
+            <a:endParaRPr/>
           </a:p>
         </p:txBody>
       </p:sp>
@@ -8053,7 +8142,7 @@
 </file>
 
 <file path=ppt/slides/slide13.xml><?xml version="1.0" encoding="utf-8"?>
-<p:sld xmlns:a="http://schemas.openxmlformats.org/drawingml/2006/main" xmlns:p="http://schemas.openxmlformats.org/presentationml/2006/main" xmlns:r="http://schemas.openxmlformats.org/officeDocument/2006/relationships">
+<p:sld xmlns:a="http://schemas.openxmlformats.org/drawingml/2006/main" xmlns:r="http://schemas.openxmlformats.org/officeDocument/2006/relationships" xmlns:p="http://schemas.openxmlformats.org/presentationml/2006/main">
   <p:cSld>
     <p:bg>
       <p:bgPr>
@@ -8069,7 +8158,14 @@
         <p:cNvGrpSpPr/>
         <p:nvPr/>
       </p:nvGrpSpPr>
-      <p:grpSpPr/>
+      <p:grpSpPr>
+        <a:xfrm>
+          <a:off x="0" y="0"/>
+          <a:ext cx="0" cy="0"/>
+          <a:chOff x="0" y="0"/>
+          <a:chExt cx="0" cy="0"/>
+        </a:xfrm>
+      </p:grpSpPr>
       <p:sp>
         <p:nvSpPr>
           <p:cNvPr id="2" name="TextBox 1"/>
@@ -8227,7 +8323,7 @@
         <p:spPr>
           <a:xfrm>
             <a:off x="9144000" y="5577840"/>
-            <a:ext cx="2194560" cy="411480"/>
+            <a:ext cx="2194560" cy="292388"/>
           </a:xfrm>
           <a:prstGeom prst="rect">
             <a:avLst/>
@@ -8249,8 +8345,10 @@
               </a:defRPr>
             </a:pPr>
             <a:r>
-              <a:t>Samiru Nuwanaka</a:t>
-            </a:r>
+              <a:rPr lang="en-US" dirty="0" err="1"/>
+              <a:t>VisionHeart</a:t>
+            </a:r>
+            <a:endParaRPr dirty="0"/>
           </a:p>
         </p:txBody>
       </p:sp>
@@ -8335,7 +8433,7 @@
 </file>
 
 <file path=ppt/slides/slide2.xml><?xml version="1.0" encoding="utf-8"?>
-<p:sld xmlns:a="http://schemas.openxmlformats.org/drawingml/2006/main" xmlns:p="http://schemas.openxmlformats.org/presentationml/2006/main" xmlns:r="http://schemas.openxmlformats.org/officeDocument/2006/relationships">
+<p:sld xmlns:a="http://schemas.openxmlformats.org/drawingml/2006/main" xmlns:r="http://schemas.openxmlformats.org/officeDocument/2006/relationships" xmlns:p="http://schemas.openxmlformats.org/presentationml/2006/main">
   <p:cSld>
     <p:bg>
       <p:bgPr>
@@ -8351,7 +8449,14 @@
         <p:cNvGrpSpPr/>
         <p:nvPr/>
       </p:nvGrpSpPr>
-      <p:grpSpPr/>
+      <p:grpSpPr>
+        <a:xfrm>
+          <a:off x="0" y="0"/>
+          <a:ext cx="0" cy="0"/>
+          <a:chOff x="0" y="0"/>
+          <a:chExt cx="0" cy="0"/>
+        </a:xfrm>
+      </p:grpSpPr>
       <p:sp>
         <p:nvSpPr>
           <p:cNvPr id="2" name="TextBox 1"/>
@@ -8502,6 +8607,7 @@
           <a:lstStyle/>
           <a:p>
             <a:pPr algn="ctr"/>
+            <a:endParaRPr/>
           </a:p>
         </p:txBody>
       </p:sp>
@@ -8545,6 +8651,7 @@
           <a:lstStyle/>
           <a:p>
             <a:pPr algn="ctr"/>
+            <a:endParaRPr/>
           </a:p>
         </p:txBody>
       </p:sp>
@@ -8738,6 +8845,7 @@
           <a:lstStyle/>
           <a:p>
             <a:pPr algn="ctr"/>
+            <a:endParaRPr/>
           </a:p>
         </p:txBody>
       </p:sp>
@@ -8781,6 +8889,7 @@
           <a:lstStyle/>
           <a:p>
             <a:pPr algn="ctr"/>
+            <a:endParaRPr/>
           </a:p>
         </p:txBody>
       </p:sp>
@@ -9080,6 +9189,7 @@
           <a:lstStyle/>
           <a:p>
             <a:pPr algn="ctr"/>
+            <a:endParaRPr/>
           </a:p>
         </p:txBody>
       </p:sp>
@@ -9200,7 +9310,7 @@
 </file>
 
 <file path=ppt/slides/slide3.xml><?xml version="1.0" encoding="utf-8"?>
-<p:sld xmlns:a="http://schemas.openxmlformats.org/drawingml/2006/main" xmlns:p="http://schemas.openxmlformats.org/presentationml/2006/main" xmlns:r="http://schemas.openxmlformats.org/officeDocument/2006/relationships">
+<p:sld xmlns:a="http://schemas.openxmlformats.org/drawingml/2006/main" xmlns:r="http://schemas.openxmlformats.org/officeDocument/2006/relationships" xmlns:p="http://schemas.openxmlformats.org/presentationml/2006/main">
   <p:cSld>
     <p:bg>
       <p:bgPr>
@@ -9216,7 +9326,14 @@
         <p:cNvGrpSpPr/>
         <p:nvPr/>
       </p:nvGrpSpPr>
-      <p:grpSpPr/>
+      <p:grpSpPr>
+        <a:xfrm>
+          <a:off x="0" y="0"/>
+          <a:ext cx="0" cy="0"/>
+          <a:chOff x="0" y="0"/>
+          <a:chExt cx="0" cy="0"/>
+        </a:xfrm>
+      </p:grpSpPr>
       <p:sp>
         <p:nvSpPr>
           <p:cNvPr id="2" name="TextBox 1"/>
@@ -9367,6 +9484,7 @@
           <a:lstStyle/>
           <a:p>
             <a:pPr algn="ctr"/>
+            <a:endParaRPr/>
           </a:p>
         </p:txBody>
       </p:sp>
@@ -9450,6 +9568,7 @@
           <a:lstStyle/>
           <a:p>
             <a:pPr algn="ctr"/>
+            <a:endParaRPr/>
           </a:p>
         </p:txBody>
       </p:sp>
@@ -9495,6 +9614,7 @@
           <a:lstStyle/>
           <a:p>
             <a:pPr algn="ctr"/>
+            <a:endParaRPr/>
           </a:p>
         </p:txBody>
       </p:sp>
@@ -9578,6 +9698,7 @@
           <a:lstStyle/>
           <a:p>
             <a:pPr algn="ctr"/>
+            <a:endParaRPr/>
           </a:p>
         </p:txBody>
       </p:sp>
@@ -9623,6 +9744,7 @@
           <a:lstStyle/>
           <a:p>
             <a:pPr algn="ctr"/>
+            <a:endParaRPr/>
           </a:p>
         </p:txBody>
       </p:sp>
@@ -9706,6 +9828,7 @@
           <a:lstStyle/>
           <a:p>
             <a:pPr algn="ctr"/>
+            <a:endParaRPr/>
           </a:p>
         </p:txBody>
       </p:sp>
@@ -9751,6 +9874,7 @@
           <a:lstStyle/>
           <a:p>
             <a:pPr algn="ctr"/>
+            <a:endParaRPr/>
           </a:p>
         </p:txBody>
       </p:sp>
@@ -9868,6 +9992,7 @@
           <a:lstStyle/>
           <a:p>
             <a:pPr algn="ctr"/>
+            <a:endParaRPr/>
           </a:p>
         </p:txBody>
       </p:sp>
@@ -10057,6 +10182,7 @@
           <a:lstStyle/>
           <a:p>
             <a:pPr algn="ctr"/>
+            <a:endParaRPr/>
           </a:p>
         </p:txBody>
       </p:sp>
@@ -10246,6 +10372,7 @@
           <a:lstStyle/>
           <a:p>
             <a:pPr algn="ctr"/>
+            <a:endParaRPr/>
           </a:p>
         </p:txBody>
       </p:sp>
@@ -10510,7 +10637,7 @@
 </file>
 
 <file path=ppt/slides/slide4.xml><?xml version="1.0" encoding="utf-8"?>
-<p:sld xmlns:a="http://schemas.openxmlformats.org/drawingml/2006/main" xmlns:p="http://schemas.openxmlformats.org/presentationml/2006/main" xmlns:r="http://schemas.openxmlformats.org/officeDocument/2006/relationships">
+<p:sld xmlns:a="http://schemas.openxmlformats.org/drawingml/2006/main" xmlns:r="http://schemas.openxmlformats.org/officeDocument/2006/relationships" xmlns:p="http://schemas.openxmlformats.org/presentationml/2006/main">
   <p:cSld>
     <p:bg>
       <p:bgPr>
@@ -10526,7 +10653,14 @@
         <p:cNvGrpSpPr/>
         <p:nvPr/>
       </p:nvGrpSpPr>
-      <p:grpSpPr/>
+      <p:grpSpPr>
+        <a:xfrm>
+          <a:off x="0" y="0"/>
+          <a:ext cx="0" cy="0"/>
+          <a:chOff x="0" y="0"/>
+          <a:chExt cx="0" cy="0"/>
+        </a:xfrm>
+      </p:grpSpPr>
       <p:sp>
         <p:nvSpPr>
           <p:cNvPr id="2" name="TextBox 1"/>
@@ -10677,6 +10811,7 @@
           <a:lstStyle/>
           <a:p>
             <a:pPr algn="ctr"/>
+            <a:endParaRPr/>
           </a:p>
         </p:txBody>
       </p:sp>
@@ -10756,6 +10891,7 @@
           <a:lstStyle/>
           <a:p>
             <a:pPr algn="ctr"/>
+            <a:endParaRPr/>
           </a:p>
         </p:txBody>
       </p:sp>
@@ -10801,6 +10937,7 @@
           <a:lstStyle/>
           <a:p>
             <a:pPr algn="ctr"/>
+            <a:endParaRPr/>
           </a:p>
         </p:txBody>
       </p:sp>
@@ -10884,6 +11021,7 @@
           <a:lstStyle/>
           <a:p>
             <a:pPr algn="ctr"/>
+            <a:endParaRPr/>
           </a:p>
         </p:txBody>
       </p:sp>
@@ -10929,6 +11067,7 @@
           <a:lstStyle/>
           <a:p>
             <a:pPr algn="ctr"/>
+            <a:endParaRPr/>
           </a:p>
         </p:txBody>
       </p:sp>
@@ -11008,6 +11147,7 @@
           <a:lstStyle/>
           <a:p>
             <a:pPr algn="ctr"/>
+            <a:endParaRPr/>
           </a:p>
         </p:txBody>
       </p:sp>
@@ -11053,6 +11193,7 @@
           <a:lstStyle/>
           <a:p>
             <a:pPr algn="ctr"/>
+            <a:endParaRPr/>
           </a:p>
         </p:txBody>
       </p:sp>
@@ -11132,6 +11273,7 @@
           <a:lstStyle/>
           <a:p>
             <a:pPr algn="ctr"/>
+            <a:endParaRPr/>
           </a:p>
         </p:txBody>
       </p:sp>
@@ -11177,6 +11319,7 @@
           <a:lstStyle/>
           <a:p>
             <a:pPr algn="ctr"/>
+            <a:endParaRPr/>
           </a:p>
         </p:txBody>
       </p:sp>
@@ -11256,6 +11399,7 @@
           <a:lstStyle/>
           <a:p>
             <a:pPr algn="ctr"/>
+            <a:endParaRPr/>
           </a:p>
         </p:txBody>
       </p:sp>
@@ -11301,6 +11445,7 @@
           <a:lstStyle/>
           <a:p>
             <a:pPr algn="ctr"/>
+            <a:endParaRPr/>
           </a:p>
         </p:txBody>
       </p:sp>
@@ -11384,6 +11529,7 @@
           <a:lstStyle/>
           <a:p>
             <a:pPr algn="ctr"/>
+            <a:endParaRPr/>
           </a:p>
         </p:txBody>
       </p:sp>
@@ -11429,6 +11575,7 @@
           <a:lstStyle/>
           <a:p>
             <a:pPr algn="ctr"/>
+            <a:endParaRPr/>
           </a:p>
         </p:txBody>
       </p:sp>
@@ -11510,6 +11657,7 @@
           <a:lstStyle/>
           <a:p>
             <a:pPr algn="ctr"/>
+            <a:endParaRPr/>
           </a:p>
         </p:txBody>
       </p:sp>
@@ -11702,7 +11850,7 @@
 </file>
 
 <file path=ppt/slides/slide5.xml><?xml version="1.0" encoding="utf-8"?>
-<p:sld xmlns:a="http://schemas.openxmlformats.org/drawingml/2006/main" xmlns:p="http://schemas.openxmlformats.org/presentationml/2006/main" xmlns:r="http://schemas.openxmlformats.org/officeDocument/2006/relationships">
+<p:sld xmlns:a="http://schemas.openxmlformats.org/drawingml/2006/main" xmlns:r="http://schemas.openxmlformats.org/officeDocument/2006/relationships" xmlns:p="http://schemas.openxmlformats.org/presentationml/2006/main">
   <p:cSld>
     <p:bg>
       <p:bgPr>
@@ -11718,7 +11866,14 @@
         <p:cNvGrpSpPr/>
         <p:nvPr/>
       </p:nvGrpSpPr>
-      <p:grpSpPr/>
+      <p:grpSpPr>
+        <a:xfrm>
+          <a:off x="0" y="0"/>
+          <a:ext cx="0" cy="0"/>
+          <a:chOff x="0" y="0"/>
+          <a:chExt cx="0" cy="0"/>
+        </a:xfrm>
+      </p:grpSpPr>
       <p:sp>
         <p:nvSpPr>
           <p:cNvPr id="2" name="TextBox 1"/>
@@ -11833,6 +11988,7 @@
           <a:lstStyle/>
           <a:p>
             <a:pPr algn="ctr"/>
+            <a:endParaRPr/>
           </a:p>
         </p:txBody>
       </p:sp>
@@ -11876,6 +12032,7 @@
           <a:lstStyle/>
           <a:p>
             <a:pPr algn="ctr"/>
+            <a:endParaRPr/>
           </a:p>
         </p:txBody>
       </p:sp>
@@ -11993,6 +12150,7 @@
           <a:lstStyle/>
           <a:p>
             <a:pPr algn="ctr"/>
+            <a:endParaRPr/>
           </a:p>
         </p:txBody>
       </p:sp>
@@ -12076,6 +12234,7 @@
           <a:lstStyle/>
           <a:p>
             <a:pPr algn="ctr"/>
+            <a:endParaRPr/>
           </a:p>
         </p:txBody>
       </p:sp>
@@ -12121,6 +12280,7 @@
           <a:lstStyle/>
           <a:p>
             <a:pPr algn="ctr"/>
+            <a:endParaRPr/>
           </a:p>
         </p:txBody>
       </p:sp>
@@ -12204,6 +12364,7 @@
           <a:lstStyle/>
           <a:p>
             <a:pPr algn="ctr"/>
+            <a:endParaRPr/>
           </a:p>
         </p:txBody>
       </p:sp>
@@ -12249,6 +12410,7 @@
           <a:lstStyle/>
           <a:p>
             <a:pPr algn="ctr"/>
+            <a:endParaRPr/>
           </a:p>
         </p:txBody>
       </p:sp>
@@ -12328,6 +12490,7 @@
           <a:lstStyle/>
           <a:p>
             <a:pPr algn="ctr"/>
+            <a:endParaRPr/>
           </a:p>
         </p:txBody>
       </p:sp>
@@ -12373,6 +12536,7 @@
           <a:lstStyle/>
           <a:p>
             <a:pPr algn="ctr"/>
+            <a:endParaRPr/>
           </a:p>
         </p:txBody>
       </p:sp>
@@ -12498,6 +12662,7 @@
           <a:lstStyle/>
           <a:p>
             <a:pPr algn="ctr"/>
+            <a:endParaRPr/>
           </a:p>
         </p:txBody>
       </p:sp>
@@ -12541,6 +12706,7 @@
           <a:lstStyle/>
           <a:p>
             <a:pPr algn="ctr"/>
+            <a:endParaRPr/>
           </a:p>
         </p:txBody>
       </p:sp>
@@ -12658,6 +12824,7 @@
           <a:lstStyle/>
           <a:p>
             <a:pPr algn="ctr"/>
+            <a:endParaRPr/>
           </a:p>
         </p:txBody>
       </p:sp>
@@ -12737,6 +12904,7 @@
           <a:lstStyle/>
           <a:p>
             <a:pPr algn="ctr"/>
+            <a:endParaRPr/>
           </a:p>
         </p:txBody>
       </p:sp>
@@ -12782,6 +12950,7 @@
           <a:lstStyle/>
           <a:p>
             <a:pPr algn="ctr"/>
+            <a:endParaRPr/>
           </a:p>
         </p:txBody>
       </p:sp>
@@ -12865,6 +13034,7 @@
           <a:lstStyle/>
           <a:p>
             <a:pPr algn="ctr"/>
+            <a:endParaRPr/>
           </a:p>
         </p:txBody>
       </p:sp>
@@ -12910,6 +13080,7 @@
           <a:lstStyle/>
           <a:p>
             <a:pPr algn="ctr"/>
+            <a:endParaRPr/>
           </a:p>
         </p:txBody>
       </p:sp>
@@ -12993,6 +13164,7 @@
           <a:lstStyle/>
           <a:p>
             <a:pPr algn="ctr"/>
+            <a:endParaRPr/>
           </a:p>
         </p:txBody>
       </p:sp>
@@ -13038,6 +13210,7 @@
           <a:lstStyle/>
           <a:p>
             <a:pPr algn="ctr"/>
+            <a:endParaRPr/>
           </a:p>
         </p:txBody>
       </p:sp>
@@ -13202,7 +13375,7 @@
 </file>
 
 <file path=ppt/slides/slide6.xml><?xml version="1.0" encoding="utf-8"?>
-<p:sld xmlns:a="http://schemas.openxmlformats.org/drawingml/2006/main" xmlns:p="http://schemas.openxmlformats.org/presentationml/2006/main" xmlns:r="http://schemas.openxmlformats.org/officeDocument/2006/relationships">
+<p:sld xmlns:a="http://schemas.openxmlformats.org/drawingml/2006/main" xmlns:r="http://schemas.openxmlformats.org/officeDocument/2006/relationships" xmlns:p="http://schemas.openxmlformats.org/presentationml/2006/main">
   <p:cSld>
     <p:bg>
       <p:bgPr>
@@ -13218,7 +13391,14 @@
         <p:cNvGrpSpPr/>
         <p:nvPr/>
       </p:nvGrpSpPr>
-      <p:grpSpPr/>
+      <p:grpSpPr>
+        <a:xfrm>
+          <a:off x="0" y="0"/>
+          <a:ext cx="0" cy="0"/>
+          <a:chOff x="0" y="0"/>
+          <a:chExt cx="0" cy="0"/>
+        </a:xfrm>
+      </p:grpSpPr>
       <p:sp>
         <p:nvSpPr>
           <p:cNvPr id="2" name="TextBox 1"/>
@@ -13369,6 +13549,7 @@
           <a:lstStyle/>
           <a:p>
             <a:pPr algn="ctr"/>
+            <a:endParaRPr/>
           </a:p>
         </p:txBody>
       </p:sp>
@@ -13450,6 +13631,7 @@
           <a:lstStyle/>
           <a:p>
             <a:pPr algn="ctr"/>
+            <a:endParaRPr/>
           </a:p>
         </p:txBody>
       </p:sp>
@@ -13531,6 +13713,7 @@
           <a:lstStyle/>
           <a:p>
             <a:pPr algn="ctr"/>
+            <a:endParaRPr/>
           </a:p>
         </p:txBody>
       </p:sp>
@@ -13724,6 +13907,7 @@
           <a:lstStyle/>
           <a:p>
             <a:pPr algn="ctr"/>
+            <a:endParaRPr/>
           </a:p>
         </p:txBody>
       </p:sp>
@@ -13915,6 +14099,7 @@
           <a:lstStyle/>
           <a:p>
             <a:pPr algn="ctr"/>
+            <a:endParaRPr/>
           </a:p>
         </p:txBody>
       </p:sp>
@@ -14035,7 +14220,7 @@
 </file>
 
 <file path=ppt/slides/slide7.xml><?xml version="1.0" encoding="utf-8"?>
-<p:sld xmlns:a="http://schemas.openxmlformats.org/drawingml/2006/main" xmlns:p="http://schemas.openxmlformats.org/presentationml/2006/main" xmlns:r="http://schemas.openxmlformats.org/officeDocument/2006/relationships">
+<p:sld xmlns:a="http://schemas.openxmlformats.org/drawingml/2006/main" xmlns:r="http://schemas.openxmlformats.org/officeDocument/2006/relationships" xmlns:p="http://schemas.openxmlformats.org/presentationml/2006/main">
   <p:cSld>
     <p:bg>
       <p:bgPr>
@@ -14051,7 +14236,14 @@
         <p:cNvGrpSpPr/>
         <p:nvPr/>
       </p:nvGrpSpPr>
-      <p:grpSpPr/>
+      <p:grpSpPr>
+        <a:xfrm>
+          <a:off x="0" y="0"/>
+          <a:ext cx="0" cy="0"/>
+          <a:chOff x="0" y="0"/>
+          <a:chExt cx="0" cy="0"/>
+        </a:xfrm>
+      </p:grpSpPr>
       <p:sp>
         <p:nvSpPr>
           <p:cNvPr id="2" name="TextBox 1"/>
@@ -14202,6 +14394,7 @@
           <a:lstStyle/>
           <a:p>
             <a:pPr algn="ctr"/>
+            <a:endParaRPr/>
           </a:p>
         </p:txBody>
       </p:sp>
@@ -14283,6 +14476,7 @@
           <a:lstStyle/>
           <a:p>
             <a:pPr algn="ctr"/>
+            <a:endParaRPr/>
           </a:p>
         </p:txBody>
       </p:sp>
@@ -14364,6 +14558,7 @@
           <a:lstStyle/>
           <a:p>
             <a:pPr algn="ctr"/>
+            <a:endParaRPr/>
           </a:p>
         </p:txBody>
       </p:sp>
@@ -14445,6 +14640,7 @@
           <a:lstStyle/>
           <a:p>
             <a:pPr algn="ctr"/>
+            <a:endParaRPr/>
           </a:p>
         </p:txBody>
       </p:sp>
@@ -14526,6 +14722,7 @@
           <a:lstStyle/>
           <a:p>
             <a:pPr algn="ctr"/>
+            <a:endParaRPr/>
           </a:p>
         </p:txBody>
       </p:sp>
@@ -14607,6 +14804,7 @@
           <a:lstStyle/>
           <a:p>
             <a:pPr algn="ctr"/>
+            <a:endParaRPr/>
           </a:p>
         </p:txBody>
       </p:sp>
@@ -14686,6 +14884,7 @@
           <a:lstStyle/>
           <a:p>
             <a:pPr algn="ctr"/>
+            <a:endParaRPr/>
           </a:p>
         </p:txBody>
       </p:sp>
@@ -14729,6 +14928,7 @@
           <a:lstStyle/>
           <a:p>
             <a:pPr algn="ctr"/>
+            <a:endParaRPr/>
           </a:p>
         </p:txBody>
       </p:sp>
@@ -14772,6 +14972,7 @@
           <a:lstStyle/>
           <a:p>
             <a:pPr algn="ctr"/>
+            <a:endParaRPr/>
           </a:p>
         </p:txBody>
       </p:sp>
@@ -14815,6 +15016,7 @@
           <a:lstStyle/>
           <a:p>
             <a:pPr algn="ctr"/>
+            <a:endParaRPr/>
           </a:p>
         </p:txBody>
       </p:sp>
@@ -14858,6 +15060,7 @@
           <a:lstStyle/>
           <a:p>
             <a:pPr algn="ctr"/>
+            <a:endParaRPr/>
           </a:p>
         </p:txBody>
       </p:sp>
@@ -14901,6 +15104,7 @@
           <a:lstStyle/>
           <a:p>
             <a:pPr algn="ctr"/>
+            <a:endParaRPr/>
           </a:p>
         </p:txBody>
       </p:sp>
@@ -14944,6 +15148,7 @@
           <a:lstStyle/>
           <a:p>
             <a:pPr algn="ctr"/>
+            <a:endParaRPr/>
           </a:p>
         </p:txBody>
       </p:sp>
@@ -14989,6 +15194,7 @@
           <a:lstStyle/>
           <a:p>
             <a:pPr algn="ctr"/>
+            <a:endParaRPr/>
           </a:p>
         </p:txBody>
       </p:sp>
@@ -15109,7 +15315,7 @@
 </file>
 
 <file path=ppt/slides/slide8.xml><?xml version="1.0" encoding="utf-8"?>
-<p:sld xmlns:a="http://schemas.openxmlformats.org/drawingml/2006/main" xmlns:p="http://schemas.openxmlformats.org/presentationml/2006/main" xmlns:r="http://schemas.openxmlformats.org/officeDocument/2006/relationships">
+<p:sld xmlns:a="http://schemas.openxmlformats.org/drawingml/2006/main" xmlns:r="http://schemas.openxmlformats.org/officeDocument/2006/relationships" xmlns:p="http://schemas.openxmlformats.org/presentationml/2006/main">
   <p:cSld>
     <p:bg>
       <p:bgPr>
@@ -15125,7 +15331,14 @@
         <p:cNvGrpSpPr/>
         <p:nvPr/>
       </p:nvGrpSpPr>
-      <p:grpSpPr/>
+      <p:grpSpPr>
+        <a:xfrm>
+          <a:off x="0" y="0"/>
+          <a:ext cx="0" cy="0"/>
+          <a:chOff x="0" y="0"/>
+          <a:chExt cx="0" cy="0"/>
+        </a:xfrm>
+      </p:grpSpPr>
       <p:sp>
         <p:nvSpPr>
           <p:cNvPr id="2" name="TextBox 1"/>
@@ -15276,6 +15489,7 @@
           <a:lstStyle/>
           <a:p>
             <a:pPr algn="ctr"/>
+            <a:endParaRPr/>
           </a:p>
         </p:txBody>
       </p:sp>
@@ -15355,6 +15569,7 @@
           <a:lstStyle/>
           <a:p>
             <a:pPr algn="ctr"/>
+            <a:endParaRPr/>
           </a:p>
         </p:txBody>
       </p:sp>
@@ -15400,6 +15615,7 @@
           <a:lstStyle/>
           <a:p>
             <a:pPr algn="ctr"/>
+            <a:endParaRPr/>
           </a:p>
         </p:txBody>
       </p:sp>
@@ -15479,6 +15695,7 @@
           <a:lstStyle/>
           <a:p>
             <a:pPr algn="ctr"/>
+            <a:endParaRPr/>
           </a:p>
         </p:txBody>
       </p:sp>
@@ -15524,6 +15741,7 @@
           <a:lstStyle/>
           <a:p>
             <a:pPr algn="ctr"/>
+            <a:endParaRPr/>
           </a:p>
         </p:txBody>
       </p:sp>
@@ -15603,6 +15821,7 @@
           <a:lstStyle/>
           <a:p>
             <a:pPr algn="ctr"/>
+            <a:endParaRPr/>
           </a:p>
         </p:txBody>
       </p:sp>
@@ -15648,6 +15867,7 @@
           <a:lstStyle/>
           <a:p>
             <a:pPr algn="ctr"/>
+            <a:endParaRPr/>
           </a:p>
         </p:txBody>
       </p:sp>
@@ -15727,6 +15947,7 @@
           <a:lstStyle/>
           <a:p>
             <a:pPr algn="ctr"/>
+            <a:endParaRPr/>
           </a:p>
         </p:txBody>
       </p:sp>
@@ -15772,6 +15993,7 @@
           <a:lstStyle/>
           <a:p>
             <a:pPr algn="ctr"/>
+            <a:endParaRPr/>
           </a:p>
         </p:txBody>
       </p:sp>
@@ -15851,6 +16073,7 @@
           <a:lstStyle/>
           <a:p>
             <a:pPr algn="ctr"/>
+            <a:endParaRPr/>
           </a:p>
         </p:txBody>
       </p:sp>
@@ -15896,6 +16119,7 @@
           <a:lstStyle/>
           <a:p>
             <a:pPr algn="ctr"/>
+            <a:endParaRPr/>
           </a:p>
         </p:txBody>
       </p:sp>
@@ -15975,6 +16199,7 @@
           <a:lstStyle/>
           <a:p>
             <a:pPr algn="ctr"/>
+            <a:endParaRPr/>
           </a:p>
         </p:txBody>
       </p:sp>
@@ -16020,6 +16245,7 @@
           <a:lstStyle/>
           <a:p>
             <a:pPr algn="ctr"/>
+            <a:endParaRPr/>
           </a:p>
         </p:txBody>
       </p:sp>
@@ -16099,6 +16325,7 @@
           <a:lstStyle/>
           <a:p>
             <a:pPr algn="ctr"/>
+            <a:endParaRPr/>
           </a:p>
         </p:txBody>
       </p:sp>
@@ -16144,6 +16371,7 @@
           <a:lstStyle/>
           <a:p>
             <a:pPr algn="ctr"/>
+            <a:endParaRPr/>
           </a:p>
         </p:txBody>
       </p:sp>
@@ -16225,6 +16453,7 @@
           <a:lstStyle/>
           <a:p>
             <a:pPr algn="ctr"/>
+            <a:endParaRPr/>
           </a:p>
         </p:txBody>
       </p:sp>
@@ -16342,6 +16571,7 @@
           <a:lstStyle/>
           <a:p>
             <a:pPr algn="ctr"/>
+            <a:endParaRPr/>
           </a:p>
         </p:txBody>
       </p:sp>
@@ -16534,7 +16764,7 @@
 </file>
 
 <file path=ppt/slides/slide9.xml><?xml version="1.0" encoding="utf-8"?>
-<p:sld xmlns:a="http://schemas.openxmlformats.org/drawingml/2006/main" xmlns:p="http://schemas.openxmlformats.org/presentationml/2006/main" xmlns:r="http://schemas.openxmlformats.org/officeDocument/2006/relationships">
+<p:sld xmlns:a="http://schemas.openxmlformats.org/drawingml/2006/main" xmlns:r="http://schemas.openxmlformats.org/officeDocument/2006/relationships" xmlns:p="http://schemas.openxmlformats.org/presentationml/2006/main">
   <p:cSld>
     <p:bg>
       <p:bgPr>
@@ -16550,7 +16780,14 @@
         <p:cNvGrpSpPr/>
         <p:nvPr/>
       </p:nvGrpSpPr>
-      <p:grpSpPr/>
+      <p:grpSpPr>
+        <a:xfrm>
+          <a:off x="0" y="0"/>
+          <a:ext cx="0" cy="0"/>
+          <a:chOff x="0" y="0"/>
+          <a:chExt cx="0" cy="0"/>
+        </a:xfrm>
+      </p:grpSpPr>
       <p:sp>
         <p:nvSpPr>
           <p:cNvPr id="2" name="TextBox 1"/>
@@ -16701,6 +16938,7 @@
           <a:lstStyle/>
           <a:p>
             <a:pPr algn="ctr"/>
+            <a:endParaRPr/>
           </a:p>
         </p:txBody>
       </p:sp>
@@ -16782,6 +17020,7 @@
           <a:lstStyle/>
           <a:p>
             <a:pPr algn="ctr"/>
+            <a:endParaRPr/>
           </a:p>
         </p:txBody>
       </p:sp>
@@ -16899,6 +17138,7 @@
           <a:lstStyle/>
           <a:p>
             <a:pPr algn="ctr"/>
+            <a:endParaRPr/>
           </a:p>
         </p:txBody>
       </p:sp>
@@ -16980,6 +17220,7 @@
           <a:lstStyle/>
           <a:p>
             <a:pPr algn="ctr"/>
+            <a:endParaRPr/>
           </a:p>
         </p:txBody>
       </p:sp>
@@ -17097,6 +17338,7 @@
           <a:lstStyle/>
           <a:p>
             <a:pPr algn="ctr"/>
+            <a:endParaRPr/>
           </a:p>
         </p:txBody>
       </p:sp>
@@ -17178,6 +17420,7 @@
           <a:lstStyle/>
           <a:p>
             <a:pPr algn="ctr"/>
+            <a:endParaRPr/>
           </a:p>
         </p:txBody>
       </p:sp>
@@ -17293,6 +17536,7 @@
           <a:lstStyle/>
           <a:p>
             <a:pPr algn="ctr"/>
+            <a:endParaRPr/>
           </a:p>
         </p:txBody>
       </p:sp>
@@ -17372,6 +17616,7 @@
           <a:lstStyle/>
           <a:p>
             <a:pPr algn="ctr"/>
+            <a:endParaRPr/>
           </a:p>
         </p:txBody>
       </p:sp>
@@ -17453,6 +17698,7 @@
           <a:lstStyle/>
           <a:p>
             <a:pPr algn="ctr"/>
+            <a:endParaRPr/>
           </a:p>
         </p:txBody>
       </p:sp>
@@ -17570,6 +17816,7 @@
           <a:lstStyle/>
           <a:p>
             <a:pPr algn="ctr"/>
+            <a:endParaRPr/>
           </a:p>
         </p:txBody>
       </p:sp>
@@ -17687,6 +17934,7 @@
           <a:lstStyle/>
           <a:p>
             <a:pPr algn="ctr"/>
+            <a:endParaRPr/>
           </a:p>
         </p:txBody>
       </p:sp>

</xml_diff>